<commit_message>
Step 1: pin deck and deck-consistency test to the snapshot; expect 3.35x / 04:05 / 11.5 h / 26.4 km / -51.5 C / 0.3 K
</commit_message>
<xml_diff>
--- a/ppt/COLDSTART_SEDHACKS26.pptx
+++ b/ppt/COLDSTART_SEDHACKS26.pptx
@@ -4379,7 +4379,7 @@
                 </a:solidFill>
                 <a:latin typeface="HK Grotesk Bold"/>
               </a:rPr>
-              <a:t>26.5 km</a:t>
+              <a:t>26.4 km</a:t>
             </a:r>
           </a:p>
         </p:txBody>
@@ -4509,7 +4509,7 @@
                 </a:solidFill>
                 <a:latin typeface="HK Grotesk Bold"/>
               </a:rPr>
-              <a:t>-52.5 C</a:t>
+              <a:t>-51.5 C</a:t>
             </a:r>
           </a:p>
         </p:txBody>
@@ -4639,7 +4639,7 @@
                 </a:solidFill>
                 <a:latin typeface="HK Grotesk Bold"/>
               </a:rPr>
-              <a:t>13 h</a:t>
+              <a:t>11.5 h</a:t>
             </a:r>
           </a:p>
         </p:txBody>
@@ -4811,7 +4811,7 @@
                 </a:solidFill>
                 <a:latin typeface="Calibri"/>
               </a:rPr>
-              <a:t>A balloon payload floats where it is -52 C and dark for 13 hours.</a:t>
+              <a:t>A balloon payload floats where it is -52 C and dark for 11.5 hours.</a:t>
             </a:r>
           </a:p>
           <a:p>
@@ -5261,7 +5261,7 @@
                 </a:solidFill>
                 <a:latin typeface="Calibri"/>
               </a:rPr>
-              <a:t>6.2 h of a 13 h night survived</a:t>
+              <a:t>6.2 h of the 11.5 h night survived</a:t>
             </a:r>
           </a:p>
         </p:txBody>
@@ -5341,7 +5341,7 @@
                 </a:solidFill>
                 <a:latin typeface="HK Grotesk Bold"/>
               </a:rPr>
-              <a:t>PASS - 3.33x margin, Rs 2468, 0.75 kg</a:t>
+              <a:t>PASS - 3.35x margin, Rs 2468, 0.75 kg</a:t>
             </a:r>
           </a:p>
           <a:p>
@@ -7194,7 +7194,7 @@
                 </a:solidFill>
                 <a:latin typeface="Calibri"/>
               </a:rPr>
-              <a:t>ATMOSPHERE (checked): our upper-air profile comes from NOAA GFS. Because one model can be biased, we cross-checked it against the independent ECMWF model - from the surface to ~20 km they agree to a mean of 0.2 K.</a:t>
+              <a:t>ATMOSPHERE (checked): our upper-air profile comes from NOAA GFS. Because one model can be biased, we cross-checked it against the independent ECMWF model - from the surface to ~20 km they agree to a mean of 0.3 K.</a:t>
             </a:r>
           </a:p>
           <a:p>
@@ -7480,7 +7480,7 @@
                 </a:solidFill>
                 <a:latin typeface="HK Grotesk Bold"/>
               </a:rPr>
-              <a:t>FAIL 04:07  |  Rs 3369  |  needs foam 1.8x better. Still fails.</a:t>
+              <a:t>FAIL 04:05  |  Rs 3369  |  needs foam 1.8x better. Still fails.</a:t>
             </a:r>
           </a:p>
           <a:p>
@@ -7518,7 +7518,7 @@
                 </a:solidFill>
                 <a:latin typeface="HK Grotesk Bold"/>
               </a:rPr>
-              <a:t>PASS 3.33x margin  |  Rs 2468  |  holds only 1 of 12 stressed scenarios</a:t>
+              <a:t>PASS 3.35x margin  |  Rs 2468  |  holds only 1 of 12 stressed scenarios</a:t>
             </a:r>
           </a:p>
           <a:p>

</xml_diff>